<commit_message>
docs: prepare repository for publication
- Rewrite README as a portfolio front page with findings, method,
  one ordered reproduction workflow, limitations and license scope
- Add MIT LICENSE for the original project code
- Refine deck wording, add slide 3 selection caveat, use stable example
  zones (enforced in verify), name the audience, fix file metadata
- Keep committed checksums on fresh downloads and document what to do
  if TLC republishes a file
- Add requirements-lock.txt, .gitattributes and an end-to-end test
- Remove internal review wording from the Phase 3 and 4 reports

Co-Authored-By: Claude Opus 5.5 (1M context) <noreply@anthropic.com>
</commit_message>
<xml_diff>
--- a/reports/nyc_taxi_executive_deck.pptx
+++ b/reports/nyc_taxi_executive_deck.pptx
@@ -5765,7 +5765,7 @@
           <a:lstStyle/>
           <a:p>
             <a:r>
-              <a:t>Data: NYC TLC Yellow Taxi trip records for January 2025 (3,475,226 raw records). Phase 2 flags rather than deletes records; 3,402,692 are eligible pickups (eligible_demand). Finding 1: Phase 3 zone and borough tables. Finding 2: Phase 3 imbalance index (P - D)/(P + D) and persistence, independently re-verified in the Phase 3 QC pass. Finding 3: Phase 4 Model A k-means with k = 5 (analyst-selected; the pre-specified rule selected k = 2). Nothing here measures ride requests, taxi supply or wait times.</a:t>
+              <a:t>Audience: a hypothetical fleet operations and dispatch planning team for NYC Yellow Taxis. Data: NYC TLC Yellow Taxi trip records for January 2025 (3,475,226 raw records). Phase 2 flags rather than deletes records; 3,402,692 are eligible pickups (eligible_demand). Finding 1: Phase 3 zone and borough tables. Finding 2: Phase 3 imbalance index (P - D)/(P + D) and persistence, recomputed independently in the Phase 3 checks. 'Recurring' means repeated within January 2025; no forecast was built or tested. Finding 3: Phase 4 Model A k-means with k = 5 (analyst-selected; the pre-specified rule selected k = 2). Nothing here measures ride requests, taxi supply or wait times.</a:t>
             </a:r>
           </a:p>
         </p:txBody>
@@ -5905,7 +5905,7 @@
           <a:lstStyle/>
           <a:p>
             <a:r>
-              <a:t>Each grey line is one non-holiday weekday in January 2025 (21 days); the navy line is the average. Average net flow is -301 trips at 08:00 and +396 at 20:00. Net flow was negative at every hour 07:00-09:59 on all 21 weekdays and positive at every hour 17:00-21:59 on all 21 weekdays. Citywide, 225 of 228 weekday zone-hours with |imbalance index| &gt;= 0.3 and &gt;= 50 trip ends per day kept the majority sign on &gt;= 90% of qualifying days (robust to stricter thresholds in the Phase 3 QC). These cells were selected for strong imbalance, so high persistence is partly expected. Net flow describes completed passenger trips only; it does not measure taxi availability, driver shortages or unmet requests.</a:t>
+              <a:t>Each grey line is one non-holiday weekday in January 2025 (21 days); the navy line is the average. Average net flow is -301 trips at 08:00 and +396 at 20:00. Net flow was negative at every hour 07:00-09:59 on all 21 weekdays and positive at every hour 17:00-21:59 on all 21 weekdays. Citywide, 225 of 228 weekday zone-hours with |imbalance index| &gt;= 0.3 and &gt;= 50 trip ends per day kept the majority sign on &gt;= 90% of qualifying days (robust to stricter thresholds in the Phase 3 sensitivity checks). These cells were selected for strong imbalance, so high persistence is partly expected. Net flow describes completed passenger trips only; it does not measure taxi availability, driver shortages or unmet requests.</a:t>
             </a:r>
           </a:p>
         </p:txBody>
@@ -9093,7 +9093,7 @@
                 </a:solidFill>
                 <a:latin typeface="Calibri"/>
               </a:rPr>
-              <a:t>EXECUTIVE SUMMARY · NYC YELLOW TAXI, JANUARY 2025</a:t>
+              <a:t>EXECUTIVE SUMMARY · NYC YELLOW TAXI, JAN 2025 · FOR A HYPOTHETICAL FLEET OPERATIONS AND DISPATCH PLANNING TEAM</a:t>
             </a:r>
           </a:p>
         </p:txBody>
@@ -9132,7 +9132,7 @@
                 </a:solidFill>
                 <a:latin typeface="Calibri"/>
               </a:rPr>
-              <a:t>Taxi activity is concentrated, directional and predictable, which supports zone- and time-specific planning</a:t>
+              <a:t>Taxi activity is concentrated, directional and recurring, which supports zone- and time-specific planning</a:t>
             </a:r>
           </a:p>
         </p:txBody>
@@ -10572,7 +10572,7 @@
                 </a:solidFill>
                 <a:latin typeface="Calibri"/>
               </a:rPr>
-              <a:t>PREDICTABLE DIRECTIONAL FLOWS · MIDTOWN CENTER</a:t>
+              <a:t>RECURRING DIRECTIONAL FLOWS · MIDTOWN CENTER</a:t>
             </a:r>
           </a:p>
         </p:txBody>
@@ -10720,7 +10720,7 @@
         </p:nvSpPr>
         <p:spPr>
           <a:xfrm>
-            <a:off x="8366760" y="3044952"/>
+            <a:off x="8366760" y="2880360"/>
             <a:ext cx="3273552" cy="548640"/>
           </a:xfrm>
           <a:prstGeom prst="rect">
@@ -10759,7 +10759,7 @@
         </p:nvSpPr>
         <p:spPr>
           <a:xfrm>
-            <a:off x="8366760" y="3611880"/>
+            <a:off x="8366760" y="3447288"/>
             <a:ext cx="3273552" cy="594360"/>
           </a:xfrm>
           <a:prstGeom prst="rect">
@@ -10798,7 +10798,7 @@
         </p:nvSpPr>
         <p:spPr>
           <a:xfrm>
-            <a:off x="8366760" y="4306824"/>
+            <a:off x="8366760" y="3977640"/>
             <a:ext cx="3273552" cy="548640"/>
           </a:xfrm>
           <a:prstGeom prst="rect">
@@ -10837,7 +10837,7 @@
         </p:nvSpPr>
         <p:spPr>
           <a:xfrm>
-            <a:off x="8366760" y="4873752"/>
+            <a:off x="8366760" y="4544568"/>
             <a:ext cx="3273552" cy="594360"/>
           </a:xfrm>
           <a:prstGeom prst="rect">
@@ -10870,14 +10870,62 @@
       </p:sp>
       <p:sp>
         <p:nvSpPr>
-          <p:cNvPr id="11" name="Definition"/>
+          <p:cNvPr id="11" name="Selection caveat"/>
+          <p:cNvSpPr txBox="1"/>
+          <p:nvPr/>
+        </p:nvSpPr>
+        <p:spPr>
+          <a:xfrm>
+            <a:off x="8366760" y="4983480"/>
+            <a:ext cx="3273552" cy="502920"/>
+          </a:xfrm>
+          <a:prstGeom prst="rect">
+            <a:avLst/>
+          </a:prstGeom>
+          <a:noFill/>
+        </p:spPr>
+        <p:txBody>
+          <a:bodyPr wrap="square" lIns="0" rIns="0" tIns="0" bIns="0" anchor="t">
+            <a:spAutoFit/>
+          </a:bodyPr>
+          <a:lstStyle/>
+          <a:p>
+            <a:pPr algn="l">
+              <a:spcAft>
+                <a:spcPts val="0"/>
+              </a:spcAft>
+            </a:pPr>
+            <a:r>
+              <a:rPr sz="1100" b="1" i="0">
+                <a:solidFill>
+                  <a:srgbClr val="1F2937"/>
+                </a:solidFill>
+                <a:latin typeface="Calibri"/>
+              </a:rPr>
+              <a:t>Caveat  </a:t>
+            </a:r>
+            <a:r>
+              <a:rPr sz="1100" b="0" i="0">
+                <a:solidFill>
+                  <a:srgbClr val="4B5563"/>
+                </a:solidFill>
+                <a:latin typeface="Calibri"/>
+              </a:rPr>
+              <a:t>Cells were selected for strong imbalance before persistence was measured, so high persistence is partly expected.</a:t>
+            </a:r>
+          </a:p>
+        </p:txBody>
+      </p:sp>
+      <p:sp>
+        <p:nvSpPr>
+          <p:cNvPr id="12" name="Definition"/>
           <p:cNvSpPr/>
           <p:nvPr/>
         </p:nvSpPr>
         <p:spPr>
           <a:xfrm>
-            <a:off x="8366760" y="5486400"/>
-            <a:ext cx="3273552" cy="713232"/>
+            <a:off x="8366760" y="5559552"/>
+            <a:ext cx="3273552" cy="676656"/>
           </a:xfrm>
           <a:prstGeom prst="roundRect">
             <a:avLst>
@@ -10916,13 +10964,13 @@
       </p:sp>
       <p:sp>
         <p:nvSpPr>
-          <p:cNvPr id="12" name="TextBox 11"/>
+          <p:cNvPr id="13" name="TextBox 12"/>
           <p:cNvSpPr txBox="1"/>
           <p:nvPr/>
         </p:nvSpPr>
         <p:spPr>
           <a:xfrm>
-            <a:off x="8531352" y="5559552"/>
+            <a:off x="8531352" y="5605272"/>
             <a:ext cx="2944368" cy="585216"/>
           </a:xfrm>
           <a:prstGeom prst="rect">
@@ -10955,7 +11003,7 @@
       </p:sp>
       <p:sp>
         <p:nvSpPr>
-          <p:cNvPr id="13" name="Source"/>
+          <p:cNvPr id="14" name="Source"/>
           <p:cNvSpPr txBox="1"/>
           <p:nvPr/>
         </p:nvSpPr>
@@ -10994,7 +11042,7 @@
       </p:sp>
       <p:sp>
         <p:nvSpPr>
-          <p:cNvPr id="14" name="Slide number"/>
+          <p:cNvPr id="15" name="Slide number"/>
           <p:cNvSpPr txBox="1"/>
           <p:nvPr/>
         </p:nvSpPr>
@@ -11352,7 +11400,7 @@
                 </a:solidFill>
                 <a:latin typeface="Calibri"/>
               </a:rPr>
-              <a:t>e.g. Upper East Side, Penn Station</a:t>
+              <a:t>e.g. Penn Station, Upper West Side</a:t>
             </a:r>
           </a:p>
         </p:txBody>
@@ -11604,7 +11652,7 @@
                 </a:solidFill>
                 <a:latin typeface="Calibri"/>
               </a:rPr>
-              <a:t>e.g. East &amp; West Village</a:t>
+              <a:t>e.g. Lower East Side, Williamsburg</a:t>
             </a:r>
           </a:p>
         </p:txBody>
@@ -11730,7 +11778,7 @@
                 </a:solidFill>
                 <a:latin typeface="Calibri"/>
               </a:rPr>
-              <a:t>e.g. East Harlem, Clinton West</a:t>
+              <a:t>e.g. Central Harlem, Long Island City</a:t>
             </a:r>
           </a:p>
         </p:txBody>
@@ -11856,7 +11904,7 @@
                 </a:solidFill>
                 <a:latin typeface="Calibri"/>
               </a:rPr>
-              <a:t>e.g. Outer Brooklyn &amp; Queens</a:t>
+              <a:t>e.g. East New York, Astoria</a:t>
             </a:r>
           </a:p>
         </p:txBody>
@@ -12093,7 +12141,7 @@
                 </a:solidFill>
                 <a:latin typeface="Calibri"/>
               </a:rPr>
-              <a:t>RECOMMENDATIONS AND VALIDATION</a:t>
+              <a:t>RECOMMENDATIONS FOR FLEET OPERATIONS AND DISPATCH PLANNING</a:t>
             </a:r>
           </a:p>
         </p:txBody>

</xml_diff>